<commit_message>
eGFR Ratio histograms: red / gray split at ratio = 1
Section 3.1 in jiaxuan_whole.qmd and Section 4 in jiaxuan_carbo.qmd
and jiaxuan_carbo_auc3.qmd now colour the ratio histogram by sign:

- Red (#E31A1C) for bins < 1 (CKD-EPI Cr-Cys eGFR below Cockcroft-
  Gault -- the sarcopenia-consistent direction)
- Grey60 for bins >= 1

A dashed grey vertical line at x = 1 marks the split; the previous
red dashed line was replaced. Bin width (0.1), percent-of-patients
y-axis, and title are unchanged.

This mirrors the red/gray convention already used by the eGFR
discordance histogram in Section 3.2 (whole), where the equivalent
cutoff of 0 is applied because discordance = CKD-EPI Cr-Cys minus
Cockcroft-Gault.

Co-Authored-By: Claude Opus 4.6 (1M context) <noreply@anthropic.com>
</commit_message>
<xml_diff>
--- a/docs/pptx/auc3/jx-auc3-egfr-ratio-hist.pptx
+++ b/docs/pptx/auc3/jx-auc3-egfr-ratio-hist.pptx
@@ -3267,8 +3267,8 @@
               <a:avLst/>
             </a:prstGeom>
             <a:solidFill>
-              <a:srgbClr val="4682B4">
-                <a:alpha val="69803"/>
+              <a:srgbClr val="E31A1C">
+                <a:alpha val="85098"/>
               </a:srgbClr>
             </a:solidFill>
             <a:ln w="13550" cap="flat">
@@ -3302,8 +3302,8 @@
               <a:avLst/>
             </a:prstGeom>
             <a:solidFill>
-              <a:srgbClr val="4682B4">
-                <a:alpha val="69803"/>
+              <a:srgbClr val="E31A1C">
+                <a:alpha val="85098"/>
               </a:srgbClr>
             </a:solidFill>
             <a:ln w="13550" cap="flat">
@@ -3337,8 +3337,8 @@
               <a:avLst/>
             </a:prstGeom>
             <a:solidFill>
-              <a:srgbClr val="4682B4">
-                <a:alpha val="69803"/>
+              <a:srgbClr val="E31A1C">
+                <a:alpha val="85098"/>
               </a:srgbClr>
             </a:solidFill>
             <a:ln w="13550" cap="flat">
@@ -3372,8 +3372,8 @@
               <a:avLst/>
             </a:prstGeom>
             <a:solidFill>
-              <a:srgbClr val="4682B4">
-                <a:alpha val="69803"/>
+              <a:srgbClr val="E31A1C">
+                <a:alpha val="85098"/>
               </a:srgbClr>
             </a:solidFill>
             <a:ln w="13550" cap="flat">
@@ -3407,8 +3407,8 @@
               <a:avLst/>
             </a:prstGeom>
             <a:solidFill>
-              <a:srgbClr val="4682B4">
-                <a:alpha val="69803"/>
+              <a:srgbClr val="E31A1C">
+                <a:alpha val="85098"/>
               </a:srgbClr>
             </a:solidFill>
             <a:ln w="13550" cap="flat">
@@ -3442,8 +3442,8 @@
               <a:avLst/>
             </a:prstGeom>
             <a:solidFill>
-              <a:srgbClr val="4682B4">
-                <a:alpha val="69803"/>
+              <a:srgbClr val="E31A1C">
+                <a:alpha val="85098"/>
               </a:srgbClr>
             </a:solidFill>
             <a:ln w="13550" cap="flat">
@@ -3471,14 +3471,14 @@
           <p:spPr>
             <a:xfrm>
               <a:off x="4302701" y="2415042"/>
-              <a:ext cx="493739" cy="3033008"/>
+              <a:ext cx="493739" cy="0"/>
             </a:xfrm>
             <a:prstGeom prst="rect">
               <a:avLst/>
             </a:prstGeom>
             <a:solidFill>
-              <a:srgbClr val="4682B4">
-                <a:alpha val="69803"/>
+              <a:srgbClr val="E31A1C">
+                <a:alpha val="85098"/>
               </a:srgbClr>
             </a:solidFill>
             <a:ln w="13550" cap="flat">
@@ -3506,14 +3506,14 @@
           <p:spPr>
             <a:xfrm>
               <a:off x="4796440" y="2687235"/>
-              <a:ext cx="493739" cy="2760815"/>
+              <a:ext cx="493739" cy="0"/>
             </a:xfrm>
             <a:prstGeom prst="rect">
               <a:avLst/>
             </a:prstGeom>
             <a:solidFill>
-              <a:srgbClr val="4682B4">
-                <a:alpha val="69803"/>
+              <a:srgbClr val="E31A1C">
+                <a:alpha val="85098"/>
               </a:srgbClr>
             </a:solidFill>
             <a:ln w="13550" cap="flat">
@@ -3541,14 +3541,14 @@
           <p:spPr>
             <a:xfrm>
               <a:off x="5290179" y="4320394"/>
-              <a:ext cx="493739" cy="1127657"/>
+              <a:ext cx="493739" cy="0"/>
             </a:xfrm>
             <a:prstGeom prst="rect">
               <a:avLst/>
             </a:prstGeom>
             <a:solidFill>
-              <a:srgbClr val="4682B4">
-                <a:alpha val="69803"/>
+              <a:srgbClr val="E31A1C">
+                <a:alpha val="85098"/>
               </a:srgbClr>
             </a:solidFill>
             <a:ln w="13550" cap="flat">
@@ -3576,14 +3576,14 @@
           <p:spPr>
             <a:xfrm>
               <a:off x="5783918" y="4553702"/>
-              <a:ext cx="493739" cy="894348"/>
+              <a:ext cx="493739" cy="0"/>
             </a:xfrm>
             <a:prstGeom prst="rect">
               <a:avLst/>
             </a:prstGeom>
             <a:solidFill>
-              <a:srgbClr val="4682B4">
-                <a:alpha val="69803"/>
+              <a:srgbClr val="E31A1C">
+                <a:alpha val="85098"/>
               </a:srgbClr>
             </a:solidFill>
             <a:ln w="13550" cap="flat">
@@ -3611,14 +3611,14 @@
           <p:spPr>
             <a:xfrm>
               <a:off x="6277658" y="5020319"/>
-              <a:ext cx="493739" cy="427731"/>
+              <a:ext cx="493739" cy="0"/>
             </a:xfrm>
             <a:prstGeom prst="rect">
               <a:avLst/>
             </a:prstGeom>
             <a:solidFill>
-              <a:srgbClr val="4682B4">
-                <a:alpha val="69803"/>
+              <a:srgbClr val="E31A1C">
+                <a:alpha val="85098"/>
               </a:srgbClr>
             </a:solidFill>
             <a:ln w="13550" cap="flat">
@@ -3646,14 +3646,14 @@
           <p:spPr>
             <a:xfrm>
               <a:off x="6771397" y="5331396"/>
-              <a:ext cx="493739" cy="116654"/>
+              <a:ext cx="493739" cy="0"/>
             </a:xfrm>
             <a:prstGeom prst="rect">
               <a:avLst/>
             </a:prstGeom>
             <a:solidFill>
-              <a:srgbClr val="4682B4">
-                <a:alpha val="69803"/>
+              <a:srgbClr val="E31A1C">
+                <a:alpha val="85098"/>
               </a:srgbClr>
             </a:solidFill>
             <a:ln w="13550" cap="flat">
@@ -3681,14 +3681,14 @@
           <p:spPr>
             <a:xfrm>
               <a:off x="7265136" y="5331396"/>
-              <a:ext cx="493739" cy="116654"/>
+              <a:ext cx="493739" cy="0"/>
             </a:xfrm>
             <a:prstGeom prst="rect">
               <a:avLst/>
             </a:prstGeom>
             <a:solidFill>
-              <a:srgbClr val="4682B4">
-                <a:alpha val="69803"/>
+              <a:srgbClr val="E31A1C">
+                <a:alpha val="85098"/>
               </a:srgbClr>
             </a:solidFill>
             <a:ln w="13550" cap="flat">
@@ -3716,14 +3716,14 @@
           <p:spPr>
             <a:xfrm>
               <a:off x="7758875" y="5409166"/>
-              <a:ext cx="493739" cy="38884"/>
+              <a:ext cx="493739" cy="0"/>
             </a:xfrm>
             <a:prstGeom prst="rect">
               <a:avLst/>
             </a:prstGeom>
             <a:solidFill>
-              <a:srgbClr val="4682B4">
-                <a:alpha val="69803"/>
+              <a:srgbClr val="E31A1C">
+                <a:alpha val="85098"/>
               </a:srgbClr>
             </a:solidFill>
             <a:ln w="13550" cap="flat">
@@ -3744,7 +3744,497 @@
         </p:sp>
         <p:sp>
           <p:nvSpPr>
-            <p:cNvPr id="41" name="pl41"/>
+            <p:cNvPr id="41" name="rc41"/>
+            <p:cNvSpPr/>
+            <p:nvPr/>
+          </p:nvSpPr>
+          <p:spPr>
+            <a:xfrm>
+              <a:off x="1340266" y="5448051"/>
+              <a:ext cx="493739" cy="0"/>
+            </a:xfrm>
+            <a:prstGeom prst="rect">
+              <a:avLst/>
+            </a:prstGeom>
+            <a:solidFill>
+              <a:srgbClr val="999999">
+                <a:alpha val="85098"/>
+              </a:srgbClr>
+            </a:solidFill>
+            <a:ln w="13550" cap="flat">
+              <a:solidFill>
+                <a:srgbClr val="000000">
+                  <a:alpha val="100000"/>
+                </a:srgbClr>
+              </a:solidFill>
+              <a:prstDash val="solid"/>
+              <a:miter/>
+            </a:ln>
+          </p:spPr>
+          <p:txBody>
+            <a:bodyPr/>
+            <a:lstStyle/>
+            <a:p/>
+          </p:txBody>
+        </p:sp>
+        <p:sp>
+          <p:nvSpPr>
+            <p:cNvPr id="42" name="rc42"/>
+            <p:cNvSpPr/>
+            <p:nvPr/>
+          </p:nvSpPr>
+          <p:spPr>
+            <a:xfrm>
+              <a:off x="1834005" y="5448051"/>
+              <a:ext cx="493739" cy="0"/>
+            </a:xfrm>
+            <a:prstGeom prst="rect">
+              <a:avLst/>
+            </a:prstGeom>
+            <a:solidFill>
+              <a:srgbClr val="999999">
+                <a:alpha val="85098"/>
+              </a:srgbClr>
+            </a:solidFill>
+            <a:ln w="13550" cap="flat">
+              <a:solidFill>
+                <a:srgbClr val="000000">
+                  <a:alpha val="100000"/>
+                </a:srgbClr>
+              </a:solidFill>
+              <a:prstDash val="solid"/>
+              <a:miter/>
+            </a:ln>
+          </p:spPr>
+          <p:txBody>
+            <a:bodyPr/>
+            <a:lstStyle/>
+            <a:p/>
+          </p:txBody>
+        </p:sp>
+        <p:sp>
+          <p:nvSpPr>
+            <p:cNvPr id="43" name="rc43"/>
+            <p:cNvSpPr/>
+            <p:nvPr/>
+          </p:nvSpPr>
+          <p:spPr>
+            <a:xfrm>
+              <a:off x="2327744" y="5448051"/>
+              <a:ext cx="493739" cy="0"/>
+            </a:xfrm>
+            <a:prstGeom prst="rect">
+              <a:avLst/>
+            </a:prstGeom>
+            <a:solidFill>
+              <a:srgbClr val="999999">
+                <a:alpha val="85098"/>
+              </a:srgbClr>
+            </a:solidFill>
+            <a:ln w="13550" cap="flat">
+              <a:solidFill>
+                <a:srgbClr val="000000">
+                  <a:alpha val="100000"/>
+                </a:srgbClr>
+              </a:solidFill>
+              <a:prstDash val="solid"/>
+              <a:miter/>
+            </a:ln>
+          </p:spPr>
+          <p:txBody>
+            <a:bodyPr/>
+            <a:lstStyle/>
+            <a:p/>
+          </p:txBody>
+        </p:sp>
+        <p:sp>
+          <p:nvSpPr>
+            <p:cNvPr id="44" name="rc44"/>
+            <p:cNvSpPr/>
+            <p:nvPr/>
+          </p:nvSpPr>
+          <p:spPr>
+            <a:xfrm>
+              <a:off x="2821484" y="5448051"/>
+              <a:ext cx="493739" cy="0"/>
+            </a:xfrm>
+            <a:prstGeom prst="rect">
+              <a:avLst/>
+            </a:prstGeom>
+            <a:solidFill>
+              <a:srgbClr val="999999">
+                <a:alpha val="85098"/>
+              </a:srgbClr>
+            </a:solidFill>
+            <a:ln w="13550" cap="flat">
+              <a:solidFill>
+                <a:srgbClr val="000000">
+                  <a:alpha val="100000"/>
+                </a:srgbClr>
+              </a:solidFill>
+              <a:prstDash val="solid"/>
+              <a:miter/>
+            </a:ln>
+          </p:spPr>
+          <p:txBody>
+            <a:bodyPr/>
+            <a:lstStyle/>
+            <a:p/>
+          </p:txBody>
+        </p:sp>
+        <p:sp>
+          <p:nvSpPr>
+            <p:cNvPr id="45" name="rc45"/>
+            <p:cNvSpPr/>
+            <p:nvPr/>
+          </p:nvSpPr>
+          <p:spPr>
+            <a:xfrm>
+              <a:off x="3315223" y="5448051"/>
+              <a:ext cx="493739" cy="0"/>
+            </a:xfrm>
+            <a:prstGeom prst="rect">
+              <a:avLst/>
+            </a:prstGeom>
+            <a:solidFill>
+              <a:srgbClr val="999999">
+                <a:alpha val="85098"/>
+              </a:srgbClr>
+            </a:solidFill>
+            <a:ln w="13550" cap="flat">
+              <a:solidFill>
+                <a:srgbClr val="000000">
+                  <a:alpha val="100000"/>
+                </a:srgbClr>
+              </a:solidFill>
+              <a:prstDash val="solid"/>
+              <a:miter/>
+            </a:ln>
+          </p:spPr>
+          <p:txBody>
+            <a:bodyPr/>
+            <a:lstStyle/>
+            <a:p/>
+          </p:txBody>
+        </p:sp>
+        <p:sp>
+          <p:nvSpPr>
+            <p:cNvPr id="46" name="rc46"/>
+            <p:cNvSpPr/>
+            <p:nvPr/>
+          </p:nvSpPr>
+          <p:spPr>
+            <a:xfrm>
+              <a:off x="3808962" y="5448051"/>
+              <a:ext cx="493739" cy="0"/>
+            </a:xfrm>
+            <a:prstGeom prst="rect">
+              <a:avLst/>
+            </a:prstGeom>
+            <a:solidFill>
+              <a:srgbClr val="999999">
+                <a:alpha val="85098"/>
+              </a:srgbClr>
+            </a:solidFill>
+            <a:ln w="13550" cap="flat">
+              <a:solidFill>
+                <a:srgbClr val="000000">
+                  <a:alpha val="100000"/>
+                </a:srgbClr>
+              </a:solidFill>
+              <a:prstDash val="solid"/>
+              <a:miter/>
+            </a:ln>
+          </p:spPr>
+          <p:txBody>
+            <a:bodyPr/>
+            <a:lstStyle/>
+            <a:p/>
+          </p:txBody>
+        </p:sp>
+        <p:sp>
+          <p:nvSpPr>
+            <p:cNvPr id="47" name="rc47"/>
+            <p:cNvSpPr/>
+            <p:nvPr/>
+          </p:nvSpPr>
+          <p:spPr>
+            <a:xfrm>
+              <a:off x="4302701" y="2415042"/>
+              <a:ext cx="493739" cy="3033008"/>
+            </a:xfrm>
+            <a:prstGeom prst="rect">
+              <a:avLst/>
+            </a:prstGeom>
+            <a:solidFill>
+              <a:srgbClr val="999999">
+                <a:alpha val="85098"/>
+              </a:srgbClr>
+            </a:solidFill>
+            <a:ln w="13550" cap="flat">
+              <a:solidFill>
+                <a:srgbClr val="000000">
+                  <a:alpha val="100000"/>
+                </a:srgbClr>
+              </a:solidFill>
+              <a:prstDash val="solid"/>
+              <a:miter/>
+            </a:ln>
+          </p:spPr>
+          <p:txBody>
+            <a:bodyPr/>
+            <a:lstStyle/>
+            <a:p/>
+          </p:txBody>
+        </p:sp>
+        <p:sp>
+          <p:nvSpPr>
+            <p:cNvPr id="48" name="rc48"/>
+            <p:cNvSpPr/>
+            <p:nvPr/>
+          </p:nvSpPr>
+          <p:spPr>
+            <a:xfrm>
+              <a:off x="4796440" y="2687235"/>
+              <a:ext cx="493739" cy="2760815"/>
+            </a:xfrm>
+            <a:prstGeom prst="rect">
+              <a:avLst/>
+            </a:prstGeom>
+            <a:solidFill>
+              <a:srgbClr val="999999">
+                <a:alpha val="85098"/>
+              </a:srgbClr>
+            </a:solidFill>
+            <a:ln w="13550" cap="flat">
+              <a:solidFill>
+                <a:srgbClr val="000000">
+                  <a:alpha val="100000"/>
+                </a:srgbClr>
+              </a:solidFill>
+              <a:prstDash val="solid"/>
+              <a:miter/>
+            </a:ln>
+          </p:spPr>
+          <p:txBody>
+            <a:bodyPr/>
+            <a:lstStyle/>
+            <a:p/>
+          </p:txBody>
+        </p:sp>
+        <p:sp>
+          <p:nvSpPr>
+            <p:cNvPr id="49" name="rc49"/>
+            <p:cNvSpPr/>
+            <p:nvPr/>
+          </p:nvSpPr>
+          <p:spPr>
+            <a:xfrm>
+              <a:off x="5290179" y="4320394"/>
+              <a:ext cx="493739" cy="1127657"/>
+            </a:xfrm>
+            <a:prstGeom prst="rect">
+              <a:avLst/>
+            </a:prstGeom>
+            <a:solidFill>
+              <a:srgbClr val="999999">
+                <a:alpha val="85098"/>
+              </a:srgbClr>
+            </a:solidFill>
+            <a:ln w="13550" cap="flat">
+              <a:solidFill>
+                <a:srgbClr val="000000">
+                  <a:alpha val="100000"/>
+                </a:srgbClr>
+              </a:solidFill>
+              <a:prstDash val="solid"/>
+              <a:miter/>
+            </a:ln>
+          </p:spPr>
+          <p:txBody>
+            <a:bodyPr/>
+            <a:lstStyle/>
+            <a:p/>
+          </p:txBody>
+        </p:sp>
+        <p:sp>
+          <p:nvSpPr>
+            <p:cNvPr id="50" name="rc50"/>
+            <p:cNvSpPr/>
+            <p:nvPr/>
+          </p:nvSpPr>
+          <p:spPr>
+            <a:xfrm>
+              <a:off x="5783918" y="4553702"/>
+              <a:ext cx="493739" cy="894348"/>
+            </a:xfrm>
+            <a:prstGeom prst="rect">
+              <a:avLst/>
+            </a:prstGeom>
+            <a:solidFill>
+              <a:srgbClr val="999999">
+                <a:alpha val="85098"/>
+              </a:srgbClr>
+            </a:solidFill>
+            <a:ln w="13550" cap="flat">
+              <a:solidFill>
+                <a:srgbClr val="000000">
+                  <a:alpha val="100000"/>
+                </a:srgbClr>
+              </a:solidFill>
+              <a:prstDash val="solid"/>
+              <a:miter/>
+            </a:ln>
+          </p:spPr>
+          <p:txBody>
+            <a:bodyPr/>
+            <a:lstStyle/>
+            <a:p/>
+          </p:txBody>
+        </p:sp>
+        <p:sp>
+          <p:nvSpPr>
+            <p:cNvPr id="51" name="rc51"/>
+            <p:cNvSpPr/>
+            <p:nvPr/>
+          </p:nvSpPr>
+          <p:spPr>
+            <a:xfrm>
+              <a:off x="6277658" y="5020319"/>
+              <a:ext cx="493739" cy="427731"/>
+            </a:xfrm>
+            <a:prstGeom prst="rect">
+              <a:avLst/>
+            </a:prstGeom>
+            <a:solidFill>
+              <a:srgbClr val="999999">
+                <a:alpha val="85098"/>
+              </a:srgbClr>
+            </a:solidFill>
+            <a:ln w="13550" cap="flat">
+              <a:solidFill>
+                <a:srgbClr val="000000">
+                  <a:alpha val="100000"/>
+                </a:srgbClr>
+              </a:solidFill>
+              <a:prstDash val="solid"/>
+              <a:miter/>
+            </a:ln>
+          </p:spPr>
+          <p:txBody>
+            <a:bodyPr/>
+            <a:lstStyle/>
+            <a:p/>
+          </p:txBody>
+        </p:sp>
+        <p:sp>
+          <p:nvSpPr>
+            <p:cNvPr id="52" name="rc52"/>
+            <p:cNvSpPr/>
+            <p:nvPr/>
+          </p:nvSpPr>
+          <p:spPr>
+            <a:xfrm>
+              <a:off x="6771397" y="5331396"/>
+              <a:ext cx="493739" cy="116654"/>
+            </a:xfrm>
+            <a:prstGeom prst="rect">
+              <a:avLst/>
+            </a:prstGeom>
+            <a:solidFill>
+              <a:srgbClr val="999999">
+                <a:alpha val="85098"/>
+              </a:srgbClr>
+            </a:solidFill>
+            <a:ln w="13550" cap="flat">
+              <a:solidFill>
+                <a:srgbClr val="000000">
+                  <a:alpha val="100000"/>
+                </a:srgbClr>
+              </a:solidFill>
+              <a:prstDash val="solid"/>
+              <a:miter/>
+            </a:ln>
+          </p:spPr>
+          <p:txBody>
+            <a:bodyPr/>
+            <a:lstStyle/>
+            <a:p/>
+          </p:txBody>
+        </p:sp>
+        <p:sp>
+          <p:nvSpPr>
+            <p:cNvPr id="53" name="rc53"/>
+            <p:cNvSpPr/>
+            <p:nvPr/>
+          </p:nvSpPr>
+          <p:spPr>
+            <a:xfrm>
+              <a:off x="7265136" y="5331396"/>
+              <a:ext cx="493739" cy="116654"/>
+            </a:xfrm>
+            <a:prstGeom prst="rect">
+              <a:avLst/>
+            </a:prstGeom>
+            <a:solidFill>
+              <a:srgbClr val="999999">
+                <a:alpha val="85098"/>
+              </a:srgbClr>
+            </a:solidFill>
+            <a:ln w="13550" cap="flat">
+              <a:solidFill>
+                <a:srgbClr val="000000">
+                  <a:alpha val="100000"/>
+                </a:srgbClr>
+              </a:solidFill>
+              <a:prstDash val="solid"/>
+              <a:miter/>
+            </a:ln>
+          </p:spPr>
+          <p:txBody>
+            <a:bodyPr/>
+            <a:lstStyle/>
+            <a:p/>
+          </p:txBody>
+        </p:sp>
+        <p:sp>
+          <p:nvSpPr>
+            <p:cNvPr id="54" name="rc54"/>
+            <p:cNvSpPr/>
+            <p:nvPr/>
+          </p:nvSpPr>
+          <p:spPr>
+            <a:xfrm>
+              <a:off x="7758875" y="5409166"/>
+              <a:ext cx="493739" cy="38884"/>
+            </a:xfrm>
+            <a:prstGeom prst="rect">
+              <a:avLst/>
+            </a:prstGeom>
+            <a:solidFill>
+              <a:srgbClr val="999999">
+                <a:alpha val="85098"/>
+              </a:srgbClr>
+            </a:solidFill>
+            <a:ln w="13550" cap="flat">
+              <a:solidFill>
+                <a:srgbClr val="000000">
+                  <a:alpha val="100000"/>
+                </a:srgbClr>
+              </a:solidFill>
+              <a:prstDash val="solid"/>
+              <a:miter/>
+            </a:ln>
+          </p:spPr>
+          <p:txBody>
+            <a:bodyPr/>
+            <a:lstStyle/>
+            <a:p/>
+          </p:txBody>
+        </p:sp>
+        <p:sp>
+          <p:nvSpPr>
+            <p:cNvPr id="55" name="pl55"/>
             <p:cNvSpPr/>
             <p:nvPr/>
           </p:nvSpPr>
@@ -3771,7 +4261,7 @@
             </a:custGeom>
             <a:ln w="13550" cap="flat">
               <a:solidFill>
-                <a:srgbClr val="FF0000">
+                <a:srgbClr val="4D4D4D">
                   <a:alpha val="100000"/>
                 </a:srgbClr>
               </a:solidFill>
@@ -3787,7 +4277,7 @@
         </p:sp>
         <p:sp>
           <p:nvSpPr>
-            <p:cNvPr id="42" name="tx42"/>
+            <p:cNvPr id="56" name="tx56"/>
             <p:cNvSpPr/>
             <p:nvPr/>
           </p:nvSpPr>
@@ -3833,7 +4323,7 @@
         </p:sp>
         <p:sp>
           <p:nvSpPr>
-            <p:cNvPr id="43" name="tx43"/>
+            <p:cNvPr id="57" name="tx57"/>
             <p:cNvSpPr/>
             <p:nvPr/>
           </p:nvSpPr>
@@ -3879,7 +4369,7 @@
         </p:sp>
         <p:sp>
           <p:nvSpPr>
-            <p:cNvPr id="44" name="tx44"/>
+            <p:cNvPr id="58" name="tx58"/>
             <p:cNvSpPr/>
             <p:nvPr/>
           </p:nvSpPr>
@@ -3925,7 +4415,7 @@
         </p:sp>
         <p:sp>
           <p:nvSpPr>
-            <p:cNvPr id="45" name="tx45"/>
+            <p:cNvPr id="59" name="tx59"/>
             <p:cNvSpPr/>
             <p:nvPr/>
           </p:nvSpPr>
@@ -3971,7 +4461,7 @@
         </p:sp>
         <p:sp>
           <p:nvSpPr>
-            <p:cNvPr id="46" name="tx46"/>
+            <p:cNvPr id="60" name="tx60"/>
             <p:cNvSpPr/>
             <p:nvPr/>
           </p:nvSpPr>
@@ -4017,7 +4507,7 @@
         </p:sp>
         <p:sp>
           <p:nvSpPr>
-            <p:cNvPr id="47" name="tx47"/>
+            <p:cNvPr id="61" name="tx61"/>
             <p:cNvSpPr/>
             <p:nvPr/>
           </p:nvSpPr>
@@ -4063,7 +4553,7 @@
         </p:sp>
         <p:sp>
           <p:nvSpPr>
-            <p:cNvPr id="48" name="tx48"/>
+            <p:cNvPr id="62" name="tx62"/>
             <p:cNvSpPr/>
             <p:nvPr/>
           </p:nvSpPr>
@@ -4109,7 +4599,7 @@
         </p:sp>
         <p:sp>
           <p:nvSpPr>
-            <p:cNvPr id="49" name="tx49"/>
+            <p:cNvPr id="63" name="tx63"/>
             <p:cNvSpPr/>
             <p:nvPr/>
           </p:nvSpPr>
@@ -4155,7 +4645,7 @@
         </p:sp>
         <p:sp>
           <p:nvSpPr>
-            <p:cNvPr id="50" name="tx50"/>
+            <p:cNvPr id="64" name="tx64"/>
             <p:cNvSpPr/>
             <p:nvPr/>
           </p:nvSpPr>
@@ -4201,7 +4691,7 @@
         </p:sp>
         <p:sp>
           <p:nvSpPr>
-            <p:cNvPr id="51" name="tx51"/>
+            <p:cNvPr id="65" name="tx65"/>
             <p:cNvSpPr/>
             <p:nvPr/>
           </p:nvSpPr>
@@ -4247,7 +4737,7 @@
         </p:sp>
         <p:sp>
           <p:nvSpPr>
-            <p:cNvPr id="52" name="tx52"/>
+            <p:cNvPr id="66" name="tx66"/>
             <p:cNvSpPr/>
             <p:nvPr/>
           </p:nvSpPr>
@@ -4293,7 +4783,7 @@
         </p:sp>
         <p:sp>
           <p:nvSpPr>
-            <p:cNvPr id="53" name="tx53"/>
+            <p:cNvPr id="67" name="tx67"/>
             <p:cNvSpPr/>
             <p:nvPr/>
           </p:nvSpPr>
@@ -4339,7 +4829,7 @@
         </p:sp>
         <p:sp>
           <p:nvSpPr>
-            <p:cNvPr id="54" name="tx54"/>
+            <p:cNvPr id="68" name="tx68"/>
             <p:cNvSpPr/>
             <p:nvPr/>
           </p:nvSpPr>
@@ -4385,7 +4875,7 @@
         </p:sp>
         <p:sp>
           <p:nvSpPr>
-            <p:cNvPr id="55" name="tx55"/>
+            <p:cNvPr id="69" name="tx69"/>
             <p:cNvSpPr/>
             <p:nvPr/>
           </p:nvSpPr>
@@ -4431,7 +4921,7 @@
         </p:sp>
         <p:sp>
           <p:nvSpPr>
-            <p:cNvPr id="56" name="tx56"/>
+            <p:cNvPr id="70" name="tx70"/>
             <p:cNvSpPr/>
             <p:nvPr/>
           </p:nvSpPr>

</xml_diff>